<commit_message>
Final MiniProject (Youtube Link: to be uploaded) [screenshots added & ppt fix]
</commit_message>
<xml_diff>
--- a/docs/NECD_PPT_Final.pptx
+++ b/docs/NECD_PPT_Final.pptx
@@ -979,7 +979,7 @@
           <p:cNvPr id="3" name="Title">
             <a:extLst>
               <a:ext uri="{FF2B5EF4-FFF2-40B4-BE49-F238E27FC236}">
-                <a16:creationId xmlns:a16="http://schemas.microsoft.com/office/drawing/2014/main" xmlns="" id="{583E6C0E-ADFD-47F0-B7F1-423099F447C9}"/>
+                <a16:creationId xmlns="" xmlns:a16="http://schemas.microsoft.com/office/drawing/2014/main" id="{583E6C0E-ADFD-47F0-B7F1-423099F447C9}"/>
               </a:ext>
             </a:extLst>
           </p:cNvPr>
@@ -1138,7 +1138,7 @@
           <p:cNvPr id="2" name="Subtitle">
             <a:extLst>
               <a:ext uri="{FF2B5EF4-FFF2-40B4-BE49-F238E27FC236}">
-                <a16:creationId xmlns:a16="http://schemas.microsoft.com/office/drawing/2014/main" xmlns="" id="{33EB337C-CD4A-4141-BBA0-4CF2780ADDB0}"/>
+                <a16:creationId xmlns="" xmlns:a16="http://schemas.microsoft.com/office/drawing/2014/main" id="{33EB337C-CD4A-4141-BBA0-4CF2780ADDB0}"/>
               </a:ext>
             </a:extLst>
           </p:cNvPr>
@@ -1322,7 +1322,7 @@
           <p:cNvPr id="2" name="Section title">
             <a:extLst>
               <a:ext uri="{FF2B5EF4-FFF2-40B4-BE49-F238E27FC236}">
-                <a16:creationId xmlns:a16="http://schemas.microsoft.com/office/drawing/2014/main" xmlns="" id="{E0CEB062-0151-4898-8FC4-ABE35F2CF9F4}"/>
+                <a16:creationId xmlns="" xmlns:a16="http://schemas.microsoft.com/office/drawing/2014/main" id="{E0CEB062-0151-4898-8FC4-ABE35F2CF9F4}"/>
               </a:ext>
             </a:extLst>
           </p:cNvPr>
@@ -1506,7 +1506,7 @@
           <p:cNvPr id="3" name="Title">
             <a:extLst>
               <a:ext uri="{FF2B5EF4-FFF2-40B4-BE49-F238E27FC236}">
-                <a16:creationId xmlns:a16="http://schemas.microsoft.com/office/drawing/2014/main" xmlns="" id="{6C25DF88-F753-4FDF-A6BB-A67DF0BF4059}"/>
+                <a16:creationId xmlns="" xmlns:a16="http://schemas.microsoft.com/office/drawing/2014/main" id="{6C25DF88-F753-4FDF-A6BB-A67DF0BF4059}"/>
               </a:ext>
             </a:extLst>
           </p:cNvPr>
@@ -1665,7 +1665,7 @@
           <p:cNvPr id="2" name="Body">
             <a:extLst>
               <a:ext uri="{FF2B5EF4-FFF2-40B4-BE49-F238E27FC236}">
-                <a16:creationId xmlns:a16="http://schemas.microsoft.com/office/drawing/2014/main" xmlns="" id="{D508D27C-B9C0-4675-8275-8B25BF40CA10}"/>
+                <a16:creationId xmlns="" xmlns:a16="http://schemas.microsoft.com/office/drawing/2014/main" id="{D508D27C-B9C0-4675-8275-8B25BF40CA10}"/>
               </a:ext>
             </a:extLst>
           </p:cNvPr>
@@ -1849,7 +1849,7 @@
           <p:cNvPr id="4" name="Title">
             <a:extLst>
               <a:ext uri="{FF2B5EF4-FFF2-40B4-BE49-F238E27FC236}">
-                <a16:creationId xmlns:a16="http://schemas.microsoft.com/office/drawing/2014/main" xmlns="" id="{700FAA36-2918-458A-BCC9-C02C5C86FD4A}"/>
+                <a16:creationId xmlns="" xmlns:a16="http://schemas.microsoft.com/office/drawing/2014/main" id="{700FAA36-2918-458A-BCC9-C02C5C86FD4A}"/>
               </a:ext>
             </a:extLst>
           </p:cNvPr>
@@ -2008,7 +2008,7 @@
           <p:cNvPr id="2" name="Left column">
             <a:extLst>
               <a:ext uri="{FF2B5EF4-FFF2-40B4-BE49-F238E27FC236}">
-                <a16:creationId xmlns:a16="http://schemas.microsoft.com/office/drawing/2014/main" xmlns="" id="{B3166FA6-9A32-40D5-BFFD-76D047ADC2B8}"/>
+                <a16:creationId xmlns="" xmlns:a16="http://schemas.microsoft.com/office/drawing/2014/main" id="{B3166FA6-9A32-40D5-BFFD-76D047ADC2B8}"/>
               </a:ext>
             </a:extLst>
           </p:cNvPr>
@@ -2167,7 +2167,7 @@
           <p:cNvPr id="3" name="Right column">
             <a:extLst>
               <a:ext uri="{FF2B5EF4-FFF2-40B4-BE49-F238E27FC236}">
-                <a16:creationId xmlns:a16="http://schemas.microsoft.com/office/drawing/2014/main" xmlns="" id="{663F08DB-F5FB-439D-8043-D5B97093E1E5}"/>
+                <a16:creationId xmlns="" xmlns:a16="http://schemas.microsoft.com/office/drawing/2014/main" id="{663F08DB-F5FB-439D-8043-D5B97093E1E5}"/>
               </a:ext>
             </a:extLst>
           </p:cNvPr>
@@ -2351,7 +2351,7 @@
           <p:cNvPr id="3" name="Title">
             <a:extLst>
               <a:ext uri="{FF2B5EF4-FFF2-40B4-BE49-F238E27FC236}">
-                <a16:creationId xmlns:a16="http://schemas.microsoft.com/office/drawing/2014/main" xmlns="" id="{43733861-E5E8-4C0E-85FF-C9C377F03DE1}"/>
+                <a16:creationId xmlns="" xmlns:a16="http://schemas.microsoft.com/office/drawing/2014/main" id="{43733861-E5E8-4C0E-85FF-C9C377F03DE1}"/>
               </a:ext>
             </a:extLst>
           </p:cNvPr>
@@ -2510,7 +2510,7 @@
           <p:cNvPr id="2" name="Left column">
             <a:extLst>
               <a:ext uri="{FF2B5EF4-FFF2-40B4-BE49-F238E27FC236}">
-                <a16:creationId xmlns:a16="http://schemas.microsoft.com/office/drawing/2014/main" xmlns="" id="{D218B774-926B-4AA9-BD18-2D17BAA20793}"/>
+                <a16:creationId xmlns="" xmlns:a16="http://schemas.microsoft.com/office/drawing/2014/main" id="{D218B774-926B-4AA9-BD18-2D17BAA20793}"/>
               </a:ext>
             </a:extLst>
           </p:cNvPr>
@@ -3040,7 +3040,7 @@
           <p:cNvPr id="9" name="Rectangle 8">
             <a:extLst>
               <a:ext uri="{FF2B5EF4-FFF2-40B4-BE49-F238E27FC236}">
-                <a16:creationId xmlns:a16="http://schemas.microsoft.com/office/drawing/2014/main" xmlns="" id="{EF37A30E-D1A0-430A-8AA0-F979BB940400}"/>
+                <a16:creationId xmlns="" xmlns:a16="http://schemas.microsoft.com/office/drawing/2014/main" id="{EF37A30E-D1A0-430A-8AA0-F979BB940400}"/>
               </a:ext>
             </a:extLst>
           </p:cNvPr>
@@ -3115,7 +3115,7 @@
           <p:cNvPr id="2" name="Rectangle 1">
             <a:extLst>
               <a:ext uri="{FF2B5EF4-FFF2-40B4-BE49-F238E27FC236}">
-                <a16:creationId xmlns:a16="http://schemas.microsoft.com/office/drawing/2014/main" xmlns="" id="{FB949E34-4B5B-4562-AC62-5E3AE182E6D9}"/>
+                <a16:creationId xmlns="" xmlns:a16="http://schemas.microsoft.com/office/drawing/2014/main" id="{FB949E34-4B5B-4562-AC62-5E3AE182E6D9}"/>
               </a:ext>
             </a:extLst>
           </p:cNvPr>
@@ -3182,7 +3182,7 @@
           <p:cNvPr id="3" name="Rectangle 2">
             <a:extLst>
               <a:ext uri="{FF2B5EF4-FFF2-40B4-BE49-F238E27FC236}">
-                <a16:creationId xmlns:a16="http://schemas.microsoft.com/office/drawing/2014/main" xmlns="" id="{3188D55E-1711-439B-B044-BD320AA1699C}"/>
+                <a16:creationId xmlns="" xmlns:a16="http://schemas.microsoft.com/office/drawing/2014/main" id="{3188D55E-1711-439B-B044-BD320AA1699C}"/>
               </a:ext>
             </a:extLst>
           </p:cNvPr>
@@ -3249,7 +3249,7 @@
           <p:cNvPr id="4" name="Picture 3">
             <a:extLst>
               <a:ext uri="{FF2B5EF4-FFF2-40B4-BE49-F238E27FC236}">
-                <a16:creationId xmlns:a16="http://schemas.microsoft.com/office/drawing/2014/main" xmlns="" id="{20500DC7-A09E-49E5-9BD7-7620F64528E8}"/>
+                <a16:creationId xmlns="" xmlns:a16="http://schemas.microsoft.com/office/drawing/2014/main" id="{20500DC7-A09E-49E5-9BD7-7620F64528E8}"/>
               </a:ext>
             </a:extLst>
           </p:cNvPr>
@@ -3277,7 +3277,7 @@
           <p:cNvPr id="5" name="Rectangle 4">
             <a:extLst>
               <a:ext uri="{FF2B5EF4-FFF2-40B4-BE49-F238E27FC236}">
-                <a16:creationId xmlns:a16="http://schemas.microsoft.com/office/drawing/2014/main" xmlns="" id="{218C27AC-3417-4BF8-804F-DF5A87976EC8}"/>
+                <a16:creationId xmlns="" xmlns:a16="http://schemas.microsoft.com/office/drawing/2014/main" id="{218C27AC-3417-4BF8-804F-DF5A87976EC8}"/>
               </a:ext>
             </a:extLst>
           </p:cNvPr>
@@ -3344,7 +3344,7 @@
           <p:cNvPr id="6" name="Rectangle 5">
             <a:extLst>
               <a:ext uri="{FF2B5EF4-FFF2-40B4-BE49-F238E27FC236}">
-                <a16:creationId xmlns:a16="http://schemas.microsoft.com/office/drawing/2014/main" xmlns="" id="{6626C341-1A4C-494A-8571-B519D932EFAE}"/>
+                <a16:creationId xmlns="" xmlns:a16="http://schemas.microsoft.com/office/drawing/2014/main" id="{6626C341-1A4C-494A-8571-B519D932EFAE}"/>
               </a:ext>
             </a:extLst>
           </p:cNvPr>
@@ -3434,7 +3434,7 @@
           <p:cNvPr id="7" name="Rectangle 6">
             <a:extLst>
               <a:ext uri="{FF2B5EF4-FFF2-40B4-BE49-F238E27FC236}">
-                <a16:creationId xmlns:a16="http://schemas.microsoft.com/office/drawing/2014/main" xmlns="" id="{45DF9F57-7481-43AF-90EA-1B438F83D4AC}"/>
+                <a16:creationId xmlns="" xmlns:a16="http://schemas.microsoft.com/office/drawing/2014/main" id="{45DF9F57-7481-43AF-90EA-1B438F83D4AC}"/>
               </a:ext>
             </a:extLst>
           </p:cNvPr>
@@ -3694,7 +3694,7 @@
           <p:cNvPr id="8" name="Rectangle 7">
             <a:extLst>
               <a:ext uri="{FF2B5EF4-FFF2-40B4-BE49-F238E27FC236}">
-                <a16:creationId xmlns:a16="http://schemas.microsoft.com/office/drawing/2014/main" xmlns="" id="{A0BBC233-AAC0-44C2-84CB-E2C2B90BE7A7}"/>
+                <a16:creationId xmlns="" xmlns:a16="http://schemas.microsoft.com/office/drawing/2014/main" id="{A0BBC233-AAC0-44C2-84CB-E2C2B90BE7A7}"/>
               </a:ext>
             </a:extLst>
           </p:cNvPr>
@@ -3980,7 +3980,7 @@
           <p:cNvPr id="7" name="Rectangle 6">
             <a:extLst>
               <a:ext uri="{FF2B5EF4-FFF2-40B4-BE49-F238E27FC236}">
-                <a16:creationId xmlns:a16="http://schemas.microsoft.com/office/drawing/2014/main" xmlns="" id="{D7465B80-86A3-4988-8BBF-D6C889F03087}"/>
+                <a16:creationId xmlns="" xmlns:a16="http://schemas.microsoft.com/office/drawing/2014/main" id="{D7465B80-86A3-4988-8BBF-D6C889F03087}"/>
               </a:ext>
             </a:extLst>
           </p:cNvPr>
@@ -4047,7 +4047,7 @@
           <p:cNvPr id="2" name="Rectangle 1">
             <a:extLst>
               <a:ext uri="{FF2B5EF4-FFF2-40B4-BE49-F238E27FC236}">
-                <a16:creationId xmlns:a16="http://schemas.microsoft.com/office/drawing/2014/main" xmlns="" id="{D35C3C1D-1A36-4479-B48D-72AED4C5126A}"/>
+                <a16:creationId xmlns="" xmlns:a16="http://schemas.microsoft.com/office/drawing/2014/main" id="{D35C3C1D-1A36-4479-B48D-72AED4C5126A}"/>
               </a:ext>
             </a:extLst>
           </p:cNvPr>
@@ -4114,7 +4114,7 @@
           <p:cNvPr id="3" name="Rectangle 2">
             <a:extLst>
               <a:ext uri="{FF2B5EF4-FFF2-40B4-BE49-F238E27FC236}">
-                <a16:creationId xmlns:a16="http://schemas.microsoft.com/office/drawing/2014/main" xmlns="" id="{83033241-AA33-4209-9B79-B06A3DA63F84}"/>
+                <a16:creationId xmlns="" xmlns:a16="http://schemas.microsoft.com/office/drawing/2014/main" id="{83033241-AA33-4209-9B79-B06A3DA63F84}"/>
               </a:ext>
             </a:extLst>
           </p:cNvPr>
@@ -4181,7 +4181,7 @@
           <p:cNvPr id="4" name="Rectangle 3">
             <a:extLst>
               <a:ext uri="{FF2B5EF4-FFF2-40B4-BE49-F238E27FC236}">
-                <a16:creationId xmlns:a16="http://schemas.microsoft.com/office/drawing/2014/main" xmlns="" id="{5C4D24D5-8342-497C-8F27-E269BD6DACDB}"/>
+                <a16:creationId xmlns="" xmlns:a16="http://schemas.microsoft.com/office/drawing/2014/main" id="{5C4D24D5-8342-497C-8F27-E269BD6DACDB}"/>
               </a:ext>
             </a:extLst>
           </p:cNvPr>
@@ -4574,7 +4574,7 @@
           <p:cNvPr id="5" name="Rectangle 4">
             <a:extLst>
               <a:ext uri="{FF2B5EF4-FFF2-40B4-BE49-F238E27FC236}">
-                <a16:creationId xmlns:a16="http://schemas.microsoft.com/office/drawing/2014/main" xmlns="" id="{8A899F11-8A11-408E-A37B-1864BB168263}"/>
+                <a16:creationId xmlns="" xmlns:a16="http://schemas.microsoft.com/office/drawing/2014/main" id="{8A899F11-8A11-408E-A37B-1864BB168263}"/>
               </a:ext>
             </a:extLst>
           </p:cNvPr>
@@ -5001,7 +5001,7 @@
           <p:cNvPr id="6" name="Rectangle 5">
             <a:extLst>
               <a:ext uri="{FF2B5EF4-FFF2-40B4-BE49-F238E27FC236}">
-                <a16:creationId xmlns:a16="http://schemas.microsoft.com/office/drawing/2014/main" xmlns="" id="{2F10ECB7-8E0C-4D51-855A-3F114DB4BE40}"/>
+                <a16:creationId xmlns="" xmlns:a16="http://schemas.microsoft.com/office/drawing/2014/main" id="{2F10ECB7-8E0C-4D51-855A-3F114DB4BE40}"/>
               </a:ext>
             </a:extLst>
           </p:cNvPr>
@@ -5114,7 +5114,7 @@
           <p:cNvPr id="6" name="Rectangle 5">
             <a:extLst>
               <a:ext uri="{FF2B5EF4-FFF2-40B4-BE49-F238E27FC236}">
-                <a16:creationId xmlns:a16="http://schemas.microsoft.com/office/drawing/2014/main" xmlns="" id="{2B87E46F-E649-4EC2-BE15-E3DC1B512D09}"/>
+                <a16:creationId xmlns="" xmlns:a16="http://schemas.microsoft.com/office/drawing/2014/main" id="{2B87E46F-E649-4EC2-BE15-E3DC1B512D09}"/>
               </a:ext>
             </a:extLst>
           </p:cNvPr>
@@ -5181,7 +5181,7 @@
           <p:cNvPr id="2" name="Rectangle 1">
             <a:extLst>
               <a:ext uri="{FF2B5EF4-FFF2-40B4-BE49-F238E27FC236}">
-                <a16:creationId xmlns:a16="http://schemas.microsoft.com/office/drawing/2014/main" xmlns="" id="{D28BC680-DAE1-4C4A-B29D-BFCE9D74EB15}"/>
+                <a16:creationId xmlns="" xmlns:a16="http://schemas.microsoft.com/office/drawing/2014/main" id="{D28BC680-DAE1-4C4A-B29D-BFCE9D74EB15}"/>
               </a:ext>
             </a:extLst>
           </p:cNvPr>
@@ -5248,7 +5248,7 @@
           <p:cNvPr id="3" name="Rectangle 2">
             <a:extLst>
               <a:ext uri="{FF2B5EF4-FFF2-40B4-BE49-F238E27FC236}">
-                <a16:creationId xmlns:a16="http://schemas.microsoft.com/office/drawing/2014/main" xmlns="" id="{52937739-9035-4330-B6E1-0CD991043B34}"/>
+                <a16:creationId xmlns="" xmlns:a16="http://schemas.microsoft.com/office/drawing/2014/main" id="{52937739-9035-4330-B6E1-0CD991043B34}"/>
               </a:ext>
             </a:extLst>
           </p:cNvPr>
@@ -5315,7 +5315,7 @@
           <p:cNvPr id="4" name="Rectangle 3">
             <a:extLst>
               <a:ext uri="{FF2B5EF4-FFF2-40B4-BE49-F238E27FC236}">
-                <a16:creationId xmlns:a16="http://schemas.microsoft.com/office/drawing/2014/main" xmlns="" id="{F08EAB2A-6F3A-412A-8E97-83E166768C45}"/>
+                <a16:creationId xmlns="" xmlns:a16="http://schemas.microsoft.com/office/drawing/2014/main" id="{F08EAB2A-6F3A-412A-8E97-83E166768C45}"/>
               </a:ext>
             </a:extLst>
           </p:cNvPr>
@@ -5600,7 +5600,7 @@
           <p:cNvPr id="8" name="Rectangle 7">
             <a:extLst>
               <a:ext uri="{FF2B5EF4-FFF2-40B4-BE49-F238E27FC236}">
-                <a16:creationId xmlns:a16="http://schemas.microsoft.com/office/drawing/2014/main" xmlns="" id="{E88AF3E2-B0A1-48D7-8AAD-58C1AE49894A}"/>
+                <a16:creationId xmlns="" xmlns:a16="http://schemas.microsoft.com/office/drawing/2014/main" id="{E88AF3E2-B0A1-48D7-8AAD-58C1AE49894A}"/>
               </a:ext>
             </a:extLst>
           </p:cNvPr>
@@ -5667,7 +5667,7 @@
           <p:cNvPr id="2" name="Rectangle 1">
             <a:extLst>
               <a:ext uri="{FF2B5EF4-FFF2-40B4-BE49-F238E27FC236}">
-                <a16:creationId xmlns:a16="http://schemas.microsoft.com/office/drawing/2014/main" xmlns="" id="{F4261110-3343-453F-B653-F85F3964BEA3}"/>
+                <a16:creationId xmlns="" xmlns:a16="http://schemas.microsoft.com/office/drawing/2014/main" id="{F4261110-3343-453F-B653-F85F3964BEA3}"/>
               </a:ext>
             </a:extLst>
           </p:cNvPr>
@@ -5734,7 +5734,7 @@
           <p:cNvPr id="3" name="Rectangle 2">
             <a:extLst>
               <a:ext uri="{FF2B5EF4-FFF2-40B4-BE49-F238E27FC236}">
-                <a16:creationId xmlns:a16="http://schemas.microsoft.com/office/drawing/2014/main" xmlns="" id="{A4034558-8083-4762-B500-1F5F6BD4A1F3}"/>
+                <a16:creationId xmlns="" xmlns:a16="http://schemas.microsoft.com/office/drawing/2014/main" id="{A4034558-8083-4762-B500-1F5F6BD4A1F3}"/>
               </a:ext>
             </a:extLst>
           </p:cNvPr>
@@ -5801,7 +5801,7 @@
           <p:cNvPr id="4" name="Rectangle 3">
             <a:extLst>
               <a:ext uri="{FF2B5EF4-FFF2-40B4-BE49-F238E27FC236}">
-                <a16:creationId xmlns:a16="http://schemas.microsoft.com/office/drawing/2014/main" xmlns="" id="{0890C7E7-A87D-46AD-AD00-B0EB9B949268}"/>
+                <a16:creationId xmlns="" xmlns:a16="http://schemas.microsoft.com/office/drawing/2014/main" id="{0890C7E7-A87D-46AD-AD00-B0EB9B949268}"/>
               </a:ext>
             </a:extLst>
           </p:cNvPr>
@@ -5868,7 +5868,7 @@
           <p:cNvPr id="5" name="Rectangle 4">
             <a:extLst>
               <a:ext uri="{FF2B5EF4-FFF2-40B4-BE49-F238E27FC236}">
-                <a16:creationId xmlns:a16="http://schemas.microsoft.com/office/drawing/2014/main" xmlns="" id="{BE9F3CB5-0C0F-4AA1-99D5-8611CF4347DB}"/>
+                <a16:creationId xmlns="" xmlns:a16="http://schemas.microsoft.com/office/drawing/2014/main" id="{BE9F3CB5-0C0F-4AA1-99D5-8611CF4347DB}"/>
               </a:ext>
             </a:extLst>
           </p:cNvPr>
@@ -5917,7 +5917,7 @@
               </a:defRPr>
             </a:pPr>
             <a:r>
-              <a:rPr lang="en-US" sz="1600" dirty="0">
+              <a:rPr lang="en-US" sz="1500" dirty="0">
                 <a:solidFill>
                   <a:srgbClr val="202020"/>
                 </a:solidFill>
@@ -5939,7 +5939,7 @@
                 <a:cs typeface="Arial"/>
               </a:defRPr>
             </a:pPr>
-            <a:endParaRPr lang="en-US" sz="1600" dirty="0">
+            <a:endParaRPr lang="en-US" sz="1500" dirty="0">
               <a:solidFill>
                 <a:srgbClr val="202020"/>
               </a:solidFill>
@@ -5960,7 +5960,7 @@
               </a:defRPr>
             </a:pPr>
             <a:r>
-              <a:rPr lang="en-US" sz="1600" dirty="0">
+              <a:rPr lang="en-US" sz="1500" dirty="0">
                 <a:solidFill>
                   <a:srgbClr val="202020"/>
                 </a:solidFill>
@@ -5970,7 +5970,7 @@
               </a:rPr>
               <a:t>Target users include computer engineering students, network administrators, and laboratory evaluators who need an interactive tool to study and demonstrate network data integrity protocols across client-router-proxy architectures.</a:t>
             </a:r>
-            <a:endParaRPr sz="1600" b="0" dirty="0">
+            <a:endParaRPr sz="1500" b="0" dirty="0">
               <a:solidFill>
                 <a:srgbClr val="202020"/>
               </a:solidFill>
@@ -5986,7 +5986,7 @@
           <p:cNvPr id="6" name="Rectangle 5">
             <a:extLst>
               <a:ext uri="{FF2B5EF4-FFF2-40B4-BE49-F238E27FC236}">
-                <a16:creationId xmlns:a16="http://schemas.microsoft.com/office/drawing/2014/main" xmlns="" id="{D4E77847-D504-4787-9F02-71CD2DC84C85}"/>
+                <a16:creationId xmlns="" xmlns:a16="http://schemas.microsoft.com/office/drawing/2014/main" id="{D4E77847-D504-4787-9F02-71CD2DC84C85}"/>
               </a:ext>
             </a:extLst>
           </p:cNvPr>
@@ -5997,7 +5997,7 @@
         </p:nvSpPr>
         <p:spPr>
           <a:xfrm>
-            <a:off x="523875" y="3722371"/>
+            <a:off x="523875" y="3640932"/>
             <a:ext cx="8096250" cy="333375"/>
           </a:xfrm>
           <a:prstGeom prst="rect">
@@ -6053,7 +6053,7 @@
           <p:cNvPr id="7" name="Rectangle 6">
             <a:extLst>
               <a:ext uri="{FF2B5EF4-FFF2-40B4-BE49-F238E27FC236}">
-                <a16:creationId xmlns:a16="http://schemas.microsoft.com/office/drawing/2014/main" xmlns="" id="{91E6E9D2-D950-4002-905E-A6DD5AE7B3CB}"/>
+                <a16:creationId xmlns="" xmlns:a16="http://schemas.microsoft.com/office/drawing/2014/main" id="{91E6E9D2-D950-4002-905E-A6DD5AE7B3CB}"/>
               </a:ext>
             </a:extLst>
           </p:cNvPr>
@@ -6064,7 +6064,7 @@
         </p:nvSpPr>
         <p:spPr>
           <a:xfrm>
-            <a:off x="476250" y="4167188"/>
+            <a:off x="476250" y="4007643"/>
             <a:ext cx="8096250" cy="1428750"/>
           </a:xfrm>
           <a:prstGeom prst="rect">
@@ -6104,7 +6104,7 @@
               </a:defRPr>
             </a:pPr>
             <a:r>
-              <a:rPr lang="en-IN" sz="1600" dirty="0">
+              <a:rPr lang="en-IN" sz="1500" dirty="0">
                 <a:solidFill>
                   <a:srgbClr val="202020"/>
                 </a:solidFill>
@@ -6115,7 +6115,7 @@
               <a:t>Design and implement a </a:t>
             </a:r>
             <a:r>
-              <a:rPr lang="en-IN" sz="1600" dirty="0" err="1">
+              <a:rPr lang="en-IN" sz="1500" dirty="0" err="1">
                 <a:solidFill>
                   <a:srgbClr val="202020"/>
                 </a:solidFill>
@@ -6126,7 +6126,7 @@
               <a:t>PyQt</a:t>
             </a:r>
             <a:r>
-              <a:rPr lang="en-IN" sz="1600" dirty="0">
+              <a:rPr lang="en-IN" sz="1500" dirty="0">
                 <a:solidFill>
                   <a:srgbClr val="202020"/>
                 </a:solidFill>
@@ -6151,7 +6151,7 @@
               </a:defRPr>
             </a:pPr>
             <a:r>
-              <a:rPr lang="en-IN" sz="1600" dirty="0">
+              <a:rPr lang="en-IN" sz="1500" dirty="0">
                 <a:solidFill>
                   <a:srgbClr val="202020"/>
                 </a:solidFill>
@@ -6176,7 +6176,7 @@
               </a:defRPr>
             </a:pPr>
             <a:r>
-              <a:rPr lang="en-IN" sz="1600" dirty="0">
+              <a:rPr lang="en-IN" sz="1500" dirty="0">
                 <a:solidFill>
                   <a:srgbClr val="202020"/>
                 </a:solidFill>
@@ -6187,7 +6187,7 @@
               <a:t>Package the application using </a:t>
             </a:r>
             <a:r>
-              <a:rPr lang="en-IN" sz="1600" dirty="0" err="1">
+              <a:rPr lang="en-IN" sz="1500" dirty="0" err="1">
                 <a:solidFill>
                   <a:srgbClr val="202020"/>
                 </a:solidFill>
@@ -6198,17 +6198,46 @@
               <a:t>PyInstaller</a:t>
             </a:r>
             <a:r>
-              <a:rPr lang="en-IN" sz="1600" dirty="0">
-                <a:solidFill>
-                  <a:srgbClr val="202020"/>
-                </a:solidFill>
-                <a:latin typeface="Arial"/>
-                <a:ea typeface="Arial"/>
-                <a:cs typeface="Arial"/>
-              </a:rPr>
-              <a:t> into a standalone, portable distribution package and evaluate system resilience under induced error conditions.</a:t>
-            </a:r>
-            <a:endParaRPr sz="1600" b="0" dirty="0">
+              <a:rPr lang="en-IN" sz="1500" dirty="0">
+                <a:solidFill>
+                  <a:srgbClr val="202020"/>
+                </a:solidFill>
+                <a:latin typeface="Arial"/>
+                <a:ea typeface="Arial"/>
+                <a:cs typeface="Arial"/>
+              </a:rPr>
+              <a:t> into a standalone, portable distribution package and evaluate system resilience under induced error conditions</a:t>
+            </a:r>
+            <a:r>
+              <a:rPr lang="en-IN" sz="1500" dirty="0" smtClean="0">
+                <a:solidFill>
+                  <a:srgbClr val="202020"/>
+                </a:solidFill>
+                <a:latin typeface="Arial"/>
+                <a:ea typeface="Arial"/>
+                <a:cs typeface="Arial"/>
+              </a:rPr>
+              <a:t>.</a:t>
+            </a:r>
+          </a:p>
+          <a:p>
+            <a:pPr marL="342900" indent="-342900" algn="just">
+              <a:buFont typeface="+mj-lt"/>
+              <a:buAutoNum type="arabicPeriod"/>
+              <a:defRPr sz="1800" b="0">
+                <a:solidFill>
+                  <a:srgbClr val="202020"/>
+                </a:solidFill>
+                <a:latin typeface="Arial"/>
+                <a:ea typeface="Arial"/>
+                <a:cs typeface="Arial"/>
+              </a:defRPr>
+            </a:pPr>
+            <a:r>
+              <a:rPr lang="en-US" sz="1500" dirty="0"/>
+              <a:t>Implement automated testing and real-time error injection frameworks to evaluate system resilience under simulated network faults and packet corruption.</a:t>
+            </a:r>
+            <a:endParaRPr sz="1500" b="0" dirty="0">
               <a:solidFill>
                 <a:srgbClr val="202020"/>
               </a:solidFill>
@@ -6262,7 +6291,7 @@
           <p:cNvPr id="6" name="Rectangle 5">
             <a:extLst>
               <a:ext uri="{FF2B5EF4-FFF2-40B4-BE49-F238E27FC236}">
-                <a16:creationId xmlns:a16="http://schemas.microsoft.com/office/drawing/2014/main" xmlns="" id="{DE2A7FE5-9330-404A-8834-8EE47CC698A1}"/>
+                <a16:creationId xmlns="" xmlns:a16="http://schemas.microsoft.com/office/drawing/2014/main" id="{DE2A7FE5-9330-404A-8834-8EE47CC698A1}"/>
               </a:ext>
             </a:extLst>
           </p:cNvPr>
@@ -6329,7 +6358,7 @@
           <p:cNvPr id="2" name="Rectangle 1">
             <a:extLst>
               <a:ext uri="{FF2B5EF4-FFF2-40B4-BE49-F238E27FC236}">
-                <a16:creationId xmlns:a16="http://schemas.microsoft.com/office/drawing/2014/main" xmlns="" id="{01186328-4620-4152-951C-0F6E0B69DF17}"/>
+                <a16:creationId xmlns="" xmlns:a16="http://schemas.microsoft.com/office/drawing/2014/main" id="{01186328-4620-4152-951C-0F6E0B69DF17}"/>
               </a:ext>
             </a:extLst>
           </p:cNvPr>
@@ -6396,7 +6425,7 @@
           <p:cNvPr id="3" name="Rectangle 2">
             <a:extLst>
               <a:ext uri="{FF2B5EF4-FFF2-40B4-BE49-F238E27FC236}">
-                <a16:creationId xmlns:a16="http://schemas.microsoft.com/office/drawing/2014/main" xmlns="" id="{D6BB9F45-CBCF-467D-B76E-7FE236AFBDA0}"/>
+                <a16:creationId xmlns="" xmlns:a16="http://schemas.microsoft.com/office/drawing/2014/main" id="{D6BB9F45-CBCF-467D-B76E-7FE236AFBDA0}"/>
               </a:ext>
             </a:extLst>
           </p:cNvPr>
@@ -6560,7 +6589,7 @@
           <p:cNvPr id="2" name="Rectangle 1">
             <a:extLst>
               <a:ext uri="{FF2B5EF4-FFF2-40B4-BE49-F238E27FC236}">
-                <a16:creationId xmlns:a16="http://schemas.microsoft.com/office/drawing/2014/main" xmlns="" id="{28FCADAF-A2C0-470E-9C4F-96082F51573B}"/>
+                <a16:creationId xmlns="" xmlns:a16="http://schemas.microsoft.com/office/drawing/2014/main" id="{28FCADAF-A2C0-470E-9C4F-96082F51573B}"/>
               </a:ext>
             </a:extLst>
           </p:cNvPr>
@@ -6824,7 +6853,7 @@
           <p:cNvPr id="3" name="Rectangle 2">
             <a:extLst>
               <a:ext uri="{FF2B5EF4-FFF2-40B4-BE49-F238E27FC236}">
-                <a16:creationId xmlns:a16="http://schemas.microsoft.com/office/drawing/2014/main" xmlns="" id="{DE2A7FE5-9330-404A-8834-8EE47CC698A1}"/>
+                <a16:creationId xmlns="" xmlns:a16="http://schemas.microsoft.com/office/drawing/2014/main" id="{DE2A7FE5-9330-404A-8834-8EE47CC698A1}"/>
               </a:ext>
             </a:extLst>
           </p:cNvPr>
@@ -6936,7 +6965,7 @@
           <p:cNvPr id="6" name="Rectangle 5">
             <a:extLst>
               <a:ext uri="{FF2B5EF4-FFF2-40B4-BE49-F238E27FC236}">
-                <a16:creationId xmlns:a16="http://schemas.microsoft.com/office/drawing/2014/main" xmlns="" id="{79D9CBCB-0357-4DC8-A188-4C37277A96D4}"/>
+                <a16:creationId xmlns="" xmlns:a16="http://schemas.microsoft.com/office/drawing/2014/main" id="{79D9CBCB-0357-4DC8-A188-4C37277A96D4}"/>
               </a:ext>
             </a:extLst>
           </p:cNvPr>
@@ -7003,7 +7032,7 @@
           <p:cNvPr id="2" name="Rectangle 1">
             <a:extLst>
               <a:ext uri="{FF2B5EF4-FFF2-40B4-BE49-F238E27FC236}">
-                <a16:creationId xmlns:a16="http://schemas.microsoft.com/office/drawing/2014/main" xmlns="" id="{A18AF794-E3C6-4991-A893-A5574F7F23BE}"/>
+                <a16:creationId xmlns="" xmlns:a16="http://schemas.microsoft.com/office/drawing/2014/main" id="{A18AF794-E3C6-4991-A893-A5574F7F23BE}"/>
               </a:ext>
             </a:extLst>
           </p:cNvPr>
@@ -7070,7 +7099,7 @@
           <p:cNvPr id="3" name="Rectangle 2">
             <a:extLst>
               <a:ext uri="{FF2B5EF4-FFF2-40B4-BE49-F238E27FC236}">
-                <a16:creationId xmlns:a16="http://schemas.microsoft.com/office/drawing/2014/main" xmlns="" id="{A5E311F0-B43D-4984-B7EF-5CED8D55A51E}"/>
+                <a16:creationId xmlns="" xmlns:a16="http://schemas.microsoft.com/office/drawing/2014/main" id="{A5E311F0-B43D-4984-B7EF-5CED8D55A51E}"/>
               </a:ext>
             </a:extLst>
           </p:cNvPr>
@@ -7137,7 +7166,7 @@
           <p:cNvPr id="4" name="Rectangle 3">
             <a:extLst>
               <a:ext uri="{FF2B5EF4-FFF2-40B4-BE49-F238E27FC236}">
-                <a16:creationId xmlns:a16="http://schemas.microsoft.com/office/drawing/2014/main" xmlns="" id="{251F08BF-264A-493B-909A-AB134824902B}"/>
+                <a16:creationId xmlns="" xmlns:a16="http://schemas.microsoft.com/office/drawing/2014/main" id="{251F08BF-264A-493B-909A-AB134824902B}"/>
               </a:ext>
             </a:extLst>
           </p:cNvPr>
@@ -7201,7 +7230,7 @@
           <p:cNvPr id="5" name="Rectangle 4">
             <a:extLst>
               <a:ext uri="{FF2B5EF4-FFF2-40B4-BE49-F238E27FC236}">
-                <a16:creationId xmlns:a16="http://schemas.microsoft.com/office/drawing/2014/main" xmlns="" id="{71B6265A-7667-4F74-BB20-92A5B1B71102}"/>
+                <a16:creationId xmlns="" xmlns:a16="http://schemas.microsoft.com/office/drawing/2014/main" id="{71B6265A-7667-4F74-BB20-92A5B1B71102}"/>
               </a:ext>
             </a:extLst>
           </p:cNvPr>
@@ -7611,7 +7640,7 @@
           <p:cNvPr id="6" name="Rectangle 5">
             <a:extLst>
               <a:ext uri="{FF2B5EF4-FFF2-40B4-BE49-F238E27FC236}">
-                <a16:creationId xmlns:a16="http://schemas.microsoft.com/office/drawing/2014/main" xmlns="" id="{C317C623-7343-44B1-AA4A-D1B4C258A90F}"/>
+                <a16:creationId xmlns="" xmlns:a16="http://schemas.microsoft.com/office/drawing/2014/main" id="{C317C623-7343-44B1-AA4A-D1B4C258A90F}"/>
               </a:ext>
             </a:extLst>
           </p:cNvPr>
@@ -7678,7 +7707,7 @@
           <p:cNvPr id="2" name="Rectangle 1">
             <a:extLst>
               <a:ext uri="{FF2B5EF4-FFF2-40B4-BE49-F238E27FC236}">
-                <a16:creationId xmlns:a16="http://schemas.microsoft.com/office/drawing/2014/main" xmlns="" id="{F1B9A461-CBBC-4245-813A-D1367A360BC7}"/>
+                <a16:creationId xmlns="" xmlns:a16="http://schemas.microsoft.com/office/drawing/2014/main" id="{F1B9A461-CBBC-4245-813A-D1367A360BC7}"/>
               </a:ext>
             </a:extLst>
           </p:cNvPr>
@@ -7745,7 +7774,7 @@
           <p:cNvPr id="3" name="Rectangle 2">
             <a:extLst>
               <a:ext uri="{FF2B5EF4-FFF2-40B4-BE49-F238E27FC236}">
-                <a16:creationId xmlns:a16="http://schemas.microsoft.com/office/drawing/2014/main" xmlns="" id="{06353FE9-3343-4C54-947B-8EB6CA4BD4B2}"/>
+                <a16:creationId xmlns="" xmlns:a16="http://schemas.microsoft.com/office/drawing/2014/main" id="{06353FE9-3343-4C54-947B-8EB6CA4BD4B2}"/>
               </a:ext>
             </a:extLst>
           </p:cNvPr>
@@ -7888,11 +7917,11 @@
   <p:clrMapOvr>
     <a:masterClrMapping/>
   </p:clrMapOvr>
-  <mc:AlternateContent xmlns:mc="http://schemas.openxmlformats.org/markup-compatibility/2006">
-    <mc:Choice xmlns:p14="http://schemas.microsoft.com/office/powerpoint/2010/main" Requires="p14">
+  <mc:AlternateContent xmlns:mc="http://schemas.openxmlformats.org/markup-compatibility/2006" xmlns:p14="http://schemas.microsoft.com/office/powerpoint/2010/main">
+    <mc:Choice Requires="p14">
       <p:transition spd="slow" p14:dur="2000"/>
     </mc:Choice>
-    <mc:Fallback>
+    <mc:Fallback xmlns="">
       <p:transition spd="slow"/>
     </mc:Fallback>
   </mc:AlternateContent>
@@ -7928,7 +7957,7 @@
           <p:cNvPr id="2" name="Rectangle 1">
             <a:extLst>
               <a:ext uri="{FF2B5EF4-FFF2-40B4-BE49-F238E27FC236}">
-                <a16:creationId xmlns:a16="http://schemas.microsoft.com/office/drawing/2014/main" xmlns="" id="{6EA10CA8-AA41-4067-AE19-358C75D267F6}"/>
+                <a16:creationId xmlns="" xmlns:a16="http://schemas.microsoft.com/office/drawing/2014/main" id="{6EA10CA8-AA41-4067-AE19-358C75D267F6}"/>
               </a:ext>
             </a:extLst>
           </p:cNvPr>
@@ -8353,7 +8382,7 @@
           <p:cNvPr id="8" name="Rectangle 7">
             <a:extLst>
               <a:ext uri="{FF2B5EF4-FFF2-40B4-BE49-F238E27FC236}">
-                <a16:creationId xmlns:a16="http://schemas.microsoft.com/office/drawing/2014/main" xmlns="" id="{3AB6F581-D019-4446-9B09-873266454C32}"/>
+                <a16:creationId xmlns="" xmlns:a16="http://schemas.microsoft.com/office/drawing/2014/main" id="{3AB6F581-D019-4446-9B09-873266454C32}"/>
               </a:ext>
             </a:extLst>
           </p:cNvPr>
@@ -8420,7 +8449,7 @@
           <p:cNvPr id="2" name="Rectangle 1">
             <a:extLst>
               <a:ext uri="{FF2B5EF4-FFF2-40B4-BE49-F238E27FC236}">
-                <a16:creationId xmlns:a16="http://schemas.microsoft.com/office/drawing/2014/main" xmlns="" id="{D9B7B2C0-778B-420B-9AC8-791FED994D01}"/>
+                <a16:creationId xmlns="" xmlns:a16="http://schemas.microsoft.com/office/drawing/2014/main" id="{D9B7B2C0-778B-420B-9AC8-791FED994D01}"/>
               </a:ext>
             </a:extLst>
           </p:cNvPr>
@@ -8487,7 +8516,7 @@
           <p:cNvPr id="3" name="Rectangle 2">
             <a:extLst>
               <a:ext uri="{FF2B5EF4-FFF2-40B4-BE49-F238E27FC236}">
-                <a16:creationId xmlns:a16="http://schemas.microsoft.com/office/drawing/2014/main" xmlns="" id="{B5A4A980-7EF8-4344-9A96-EEAF374C7B47}"/>
+                <a16:creationId xmlns="" xmlns:a16="http://schemas.microsoft.com/office/drawing/2014/main" id="{B5A4A980-7EF8-4344-9A96-EEAF374C7B47}"/>
               </a:ext>
             </a:extLst>
           </p:cNvPr>
@@ -8554,7 +8583,7 @@
           <p:cNvPr id="4" name="Rectangle 3">
             <a:extLst>
               <a:ext uri="{FF2B5EF4-FFF2-40B4-BE49-F238E27FC236}">
-                <a16:creationId xmlns:a16="http://schemas.microsoft.com/office/drawing/2014/main" xmlns="" id="{D61DD762-53EC-4E66-840B-4BC66B5F54C7}"/>
+                <a16:creationId xmlns="" xmlns:a16="http://schemas.microsoft.com/office/drawing/2014/main" id="{D61DD762-53EC-4E66-840B-4BC66B5F54C7}"/>
               </a:ext>
             </a:extLst>
           </p:cNvPr>
@@ -8621,7 +8650,7 @@
           <p:cNvPr id="5" name="Rectangle 4">
             <a:extLst>
               <a:ext uri="{FF2B5EF4-FFF2-40B4-BE49-F238E27FC236}">
-                <a16:creationId xmlns:a16="http://schemas.microsoft.com/office/drawing/2014/main" xmlns="" id="{E7D0DFDA-9D38-4110-9E96-AA8B9885772D}"/>
+                <a16:creationId xmlns="" xmlns:a16="http://schemas.microsoft.com/office/drawing/2014/main" id="{E7D0DFDA-9D38-4110-9E96-AA8B9885772D}"/>
               </a:ext>
             </a:extLst>
           </p:cNvPr>
@@ -8707,7 +8736,7 @@
           <p:cNvPr id="6" name="Rectangle 5">
             <a:extLst>
               <a:ext uri="{FF2B5EF4-FFF2-40B4-BE49-F238E27FC236}">
-                <a16:creationId xmlns:a16="http://schemas.microsoft.com/office/drawing/2014/main" xmlns="" id="{A981F47A-2B1A-4750-8E3C-EC82A2551A9A}"/>
+                <a16:creationId xmlns="" xmlns:a16="http://schemas.microsoft.com/office/drawing/2014/main" id="{A981F47A-2B1A-4750-8E3C-EC82A2551A9A}"/>
               </a:ext>
             </a:extLst>
           </p:cNvPr>

</xml_diff>